<commit_message>
Refine peak flux heatmap visualization and add inducible secondary response ODE models
Further enhances the peak flux heatmap by applying log10 scaling to the flux (z-axis), defining dynamic contour levels, improving axis labels, and saving the output to a PNG file. Additionally, this commit introduces new ODE models to simulate and compare inducible plasma cell dynamics against a non-inducible baseline, providing insights into secondary antibody responses.
</commit_message>
<xml_diff>
--- a/results/paper_figs.pptx
+++ b/results/paper_figs.pptx
@@ -8,6 +8,8 @@
     <p:sldId id="256" r:id="rId2"/>
     <p:sldId id="257" r:id="rId3"/>
     <p:sldId id="258" r:id="rId4"/>
+    <p:sldId id="259" r:id="rId5"/>
+    <p:sldId id="260" r:id="rId6"/>
   </p:sldIdLst>
   <p:sldSz cx="12192000" cy="6858000"/>
   <p:notesSz cx="6858000" cy="9144000"/>
@@ -106,6 +108,11 @@
       </a:defRPr>
     </a:lvl9pPr>
   </p:defaultTextStyle>
+  <p:extLst>
+    <p:ext uri="{EFAFB233-063F-42B5-8137-9DF3F51BA10A}">
+      <p15:sldGuideLst xmlns:p15="http://schemas.microsoft.com/office/powerpoint/2012/main"/>
+    </p:ext>
+  </p:extLst>
 </p:presentation>
 </file>
 
@@ -256,7 +263,7 @@
           <a:p>
             <a:fld id="{405C2787-FC8B-5342-AB03-676DFA569478}" type="datetimeFigureOut">
               <a:rPr lang="en-US" smtClean="0"/>
-              <a:t>10/2/26</a:t>
+              <a:t>10/9/26</a:t>
             </a:fld>
             <a:endParaRPr lang="en-US"/>
           </a:p>
@@ -454,7 +461,7 @@
           <a:p>
             <a:fld id="{405C2787-FC8B-5342-AB03-676DFA569478}" type="datetimeFigureOut">
               <a:rPr lang="en-US" smtClean="0"/>
-              <a:t>10/2/26</a:t>
+              <a:t>10/9/26</a:t>
             </a:fld>
             <a:endParaRPr lang="en-US"/>
           </a:p>
@@ -662,7 +669,7 @@
           <a:p>
             <a:fld id="{405C2787-FC8B-5342-AB03-676DFA569478}" type="datetimeFigureOut">
               <a:rPr lang="en-US" smtClean="0"/>
-              <a:t>10/2/26</a:t>
+              <a:t>10/9/26</a:t>
             </a:fld>
             <a:endParaRPr lang="en-US"/>
           </a:p>
@@ -860,7 +867,7 @@
           <a:p>
             <a:fld id="{405C2787-FC8B-5342-AB03-676DFA569478}" type="datetimeFigureOut">
               <a:rPr lang="en-US" smtClean="0"/>
-              <a:t>10/2/26</a:t>
+              <a:t>10/9/26</a:t>
             </a:fld>
             <a:endParaRPr lang="en-US"/>
           </a:p>
@@ -1135,7 +1142,7 @@
           <a:p>
             <a:fld id="{405C2787-FC8B-5342-AB03-676DFA569478}" type="datetimeFigureOut">
               <a:rPr lang="en-US" smtClean="0"/>
-              <a:t>10/2/26</a:t>
+              <a:t>10/9/26</a:t>
             </a:fld>
             <a:endParaRPr lang="en-US"/>
           </a:p>
@@ -1400,7 +1407,7 @@
           <a:p>
             <a:fld id="{405C2787-FC8B-5342-AB03-676DFA569478}" type="datetimeFigureOut">
               <a:rPr lang="en-US" smtClean="0"/>
-              <a:t>10/2/26</a:t>
+              <a:t>10/9/26</a:t>
             </a:fld>
             <a:endParaRPr lang="en-US"/>
           </a:p>
@@ -1812,7 +1819,7 @@
           <a:p>
             <a:fld id="{405C2787-FC8B-5342-AB03-676DFA569478}" type="datetimeFigureOut">
               <a:rPr lang="en-US" smtClean="0"/>
-              <a:t>10/2/26</a:t>
+              <a:t>10/9/26</a:t>
             </a:fld>
             <a:endParaRPr lang="en-US"/>
           </a:p>
@@ -1953,7 +1960,7 @@
           <a:p>
             <a:fld id="{405C2787-FC8B-5342-AB03-676DFA569478}" type="datetimeFigureOut">
               <a:rPr lang="en-US" smtClean="0"/>
-              <a:t>10/2/26</a:t>
+              <a:t>10/9/26</a:t>
             </a:fld>
             <a:endParaRPr lang="en-US"/>
           </a:p>
@@ -2066,7 +2073,7 @@
           <a:p>
             <a:fld id="{405C2787-FC8B-5342-AB03-676DFA569478}" type="datetimeFigureOut">
               <a:rPr lang="en-US" smtClean="0"/>
-              <a:t>10/2/26</a:t>
+              <a:t>10/9/26</a:t>
             </a:fld>
             <a:endParaRPr lang="en-US"/>
           </a:p>
@@ -2377,7 +2384,7 @@
           <a:p>
             <a:fld id="{405C2787-FC8B-5342-AB03-676DFA569478}" type="datetimeFigureOut">
               <a:rPr lang="en-US" smtClean="0"/>
-              <a:t>10/2/26</a:t>
+              <a:t>10/9/26</a:t>
             </a:fld>
             <a:endParaRPr lang="en-US"/>
           </a:p>
@@ -2665,7 +2672,7 @@
           <a:p>
             <a:fld id="{405C2787-FC8B-5342-AB03-676DFA569478}" type="datetimeFigureOut">
               <a:rPr lang="en-US" smtClean="0"/>
-              <a:t>10/2/26</a:t>
+              <a:t>10/9/26</a:t>
             </a:fld>
             <a:endParaRPr lang="en-US"/>
           </a:p>
@@ -2906,7 +2913,7 @@
           <a:p>
             <a:fld id="{405C2787-FC8B-5342-AB03-676DFA569478}" type="datetimeFigureOut">
               <a:rPr lang="en-US" smtClean="0"/>
-              <a:t>10/2/26</a:t>
+              <a:t>10/9/26</a:t>
             </a:fld>
             <a:endParaRPr lang="en-US"/>
           </a:p>
@@ -3466,10 +3473,10 @@
       </p:grpSpPr>
       <p:pic>
         <p:nvPicPr>
-          <p:cNvPr id="7" name="Picture 6">
-            <a:extLst>
-              <a:ext uri="{FF2B5EF4-FFF2-40B4-BE49-F238E27FC236}">
-                <a16:creationId xmlns:a16="http://schemas.microsoft.com/office/drawing/2014/main" id="{43E836C2-04DC-88F1-B22E-0EE1778B0B0B}"/>
+          <p:cNvPr id="3" name="Picture 2">
+            <a:extLst>
+              <a:ext uri="{FF2B5EF4-FFF2-40B4-BE49-F238E27FC236}">
+                <a16:creationId xmlns:a16="http://schemas.microsoft.com/office/drawing/2014/main" id="{93E8845C-0C35-28F0-6D68-14E295A23567}"/>
               </a:ext>
             </a:extLst>
           </p:cNvPr>
@@ -3486,8 +3493,8 @@
         </p:blipFill>
         <p:spPr>
           <a:xfrm>
-            <a:off x="790660" y="1034363"/>
-            <a:ext cx="10114333" cy="4789273"/>
+            <a:off x="2557274" y="1596975"/>
+            <a:ext cx="7772400" cy="3664049"/>
           </a:xfrm>
           <a:prstGeom prst="rect">
             <a:avLst/>
@@ -3498,6 +3505,160 @@
     <p:extLst>
       <p:ext uri="{BB962C8B-B14F-4D97-AF65-F5344CB8AC3E}">
         <p14:creationId xmlns:p14="http://schemas.microsoft.com/office/powerpoint/2010/main" val="1252550374"/>
+      </p:ext>
+    </p:extLst>
+  </p:cSld>
+  <p:clrMapOvr>
+    <a:masterClrMapping/>
+  </p:clrMapOvr>
+</p:sld>
+</file>
+
+<file path=ppt/slides/slide4.xml><?xml version="1.0" encoding="utf-8"?>
+<p:sld xmlns:a="http://schemas.openxmlformats.org/drawingml/2006/main" xmlns:r="http://schemas.openxmlformats.org/officeDocument/2006/relationships" xmlns:p="http://schemas.openxmlformats.org/presentationml/2006/main">
+  <p:cSld>
+    <p:spTree>
+      <p:nvGrpSpPr>
+        <p:cNvPr id="1" name=""/>
+        <p:cNvGrpSpPr/>
+        <p:nvPr/>
+      </p:nvGrpSpPr>
+      <p:grpSpPr>
+        <a:xfrm>
+          <a:off x="0" y="0"/>
+          <a:ext cx="0" cy="0"/>
+          <a:chOff x="0" y="0"/>
+          <a:chExt cx="0" cy="0"/>
+        </a:xfrm>
+      </p:grpSpPr>
+      <p:pic>
+        <p:nvPicPr>
+          <p:cNvPr id="5" name="Content Placeholder 4">
+            <a:extLst>
+              <a:ext uri="{FF2B5EF4-FFF2-40B4-BE49-F238E27FC236}">
+                <a16:creationId xmlns:a16="http://schemas.microsoft.com/office/drawing/2014/main" id="{E774989D-6C75-AD53-2324-0640BE56417C}"/>
+              </a:ext>
+            </a:extLst>
+          </p:cNvPr>
+          <p:cNvPicPr>
+            <a:picLocks noGrp="1" noChangeAspect="1"/>
+          </p:cNvPicPr>
+          <p:nvPr>
+            <p:ph idx="1"/>
+          </p:nvPr>
+        </p:nvPicPr>
+        <p:blipFill>
+          <a:blip r:embed="rId2"/>
+          <a:stretch>
+            <a:fillRect/>
+          </a:stretch>
+        </p:blipFill>
+        <p:spPr>
+          <a:xfrm>
+            <a:off x="0" y="2088292"/>
+            <a:ext cx="6096000" cy="3657600"/>
+          </a:xfrm>
+          <a:prstGeom prst="rect">
+            <a:avLst/>
+          </a:prstGeom>
+        </p:spPr>
+      </p:pic>
+      <p:pic>
+        <p:nvPicPr>
+          <p:cNvPr id="9" name="Picture 8">
+            <a:extLst>
+              <a:ext uri="{FF2B5EF4-FFF2-40B4-BE49-F238E27FC236}">
+                <a16:creationId xmlns:a16="http://schemas.microsoft.com/office/drawing/2014/main" id="{AB87F432-A938-CC72-C72B-8A40C9380D3B}"/>
+              </a:ext>
+            </a:extLst>
+          </p:cNvPr>
+          <p:cNvPicPr>
+            <a:picLocks noChangeAspect="1"/>
+          </p:cNvPicPr>
+          <p:nvPr/>
+        </p:nvPicPr>
+        <p:blipFill>
+          <a:blip r:embed="rId3"/>
+          <a:stretch>
+            <a:fillRect/>
+          </a:stretch>
+        </p:blipFill>
+        <p:spPr>
+          <a:xfrm>
+            <a:off x="6096000" y="2088292"/>
+            <a:ext cx="6096000" cy="3657600"/>
+          </a:xfrm>
+          <a:prstGeom prst="rect">
+            <a:avLst/>
+          </a:prstGeom>
+        </p:spPr>
+      </p:pic>
+    </p:spTree>
+    <p:extLst>
+      <p:ext uri="{BB962C8B-B14F-4D97-AF65-F5344CB8AC3E}">
+        <p14:creationId xmlns:p14="http://schemas.microsoft.com/office/powerpoint/2010/main" val="611312373"/>
+      </p:ext>
+    </p:extLst>
+  </p:cSld>
+  <p:clrMapOvr>
+    <a:masterClrMapping/>
+  </p:clrMapOvr>
+</p:sld>
+</file>
+
+<file path=ppt/slides/slide5.xml><?xml version="1.0" encoding="utf-8"?>
+<p:sld xmlns:a="http://schemas.openxmlformats.org/drawingml/2006/main" xmlns:r="http://schemas.openxmlformats.org/officeDocument/2006/relationships" xmlns:p="http://schemas.openxmlformats.org/presentationml/2006/main">
+  <p:cSld>
+    <p:spTree>
+      <p:nvGrpSpPr>
+        <p:cNvPr id="1" name=""/>
+        <p:cNvGrpSpPr/>
+        <p:nvPr/>
+      </p:nvGrpSpPr>
+      <p:grpSpPr>
+        <a:xfrm>
+          <a:off x="0" y="0"/>
+          <a:ext cx="0" cy="0"/>
+          <a:chOff x="0" y="0"/>
+          <a:chExt cx="0" cy="0"/>
+        </a:xfrm>
+      </p:grpSpPr>
+      <p:pic>
+        <p:nvPicPr>
+          <p:cNvPr id="9" name="Content Placeholder 8">
+            <a:extLst>
+              <a:ext uri="{FF2B5EF4-FFF2-40B4-BE49-F238E27FC236}">
+                <a16:creationId xmlns:a16="http://schemas.microsoft.com/office/drawing/2014/main" id="{3729BC0D-56B4-2E62-1698-1AEA5E6484F5}"/>
+              </a:ext>
+            </a:extLst>
+          </p:cNvPr>
+          <p:cNvPicPr>
+            <a:picLocks noGrp="1" noChangeAspect="1"/>
+          </p:cNvPicPr>
+          <p:nvPr>
+            <p:ph idx="1"/>
+          </p:nvPr>
+        </p:nvPicPr>
+        <p:blipFill>
+          <a:blip r:embed="rId2"/>
+          <a:stretch>
+            <a:fillRect/>
+          </a:stretch>
+        </p:blipFill>
+        <p:spPr>
+          <a:xfrm>
+            <a:off x="2393092" y="1851218"/>
+            <a:ext cx="6096000" cy="3657600"/>
+          </a:xfrm>
+          <a:prstGeom prst="rect">
+            <a:avLst/>
+          </a:prstGeom>
+        </p:spPr>
+      </p:pic>
+    </p:spTree>
+    <p:extLst>
+      <p:ext uri="{BB962C8B-B14F-4D97-AF65-F5344CB8AC3E}">
+        <p14:creationId xmlns:p14="http://schemas.microsoft.com/office/powerpoint/2010/main" val="2971656722"/>
       </p:ext>
     </p:extLst>
   </p:cSld>

</xml_diff>